<commit_message>
Add live demo and GitHub links to the pitch deck
</commit_message>
<xml_diff>
--- a/pitch/DukaanPulse_AI_Pitch.pptx
+++ b/pitch/DukaanPulse_AI_Pitch.pptx
@@ -122,18 +122,18 @@
   <p:extLst>
     <p:ext uri="{521415D9-36F7-43E2-AB2F-B90AF26B5E84}">
       <p14:sectionLst xmlns:p14="http://schemas.microsoft.com/office/powerpoint/2010/main">
-        <p14:section name="Title" id="{8c81e89a-fc55-7cb2-6e34-63ac013e6b02}">
+        <p14:section name="Title" id="{6dea3157-4591-7ec0-5652-a69a650e0cf4}">
           <p14:sldIdLst>
             <p14:sldId id="256"/>
           </p14:sldIdLst>
         </p14:section>
-        <p14:section name="Problem Statement" id="{d5ccb034-9065-f390-8e6b-bb2d55f8b711}">
+        <p14:section name="Problem Statement" id="{21550aa0-9d0a-4a59-12e2-e06032a59256}">
           <p14:sldIdLst>
             <p14:sldId id="257"/>
             <p14:sldId id="258"/>
           </p14:sldIdLst>
         </p14:section>
-        <p14:section name="Proposed Solution" id="{84081da4-9abd-c47f-4411-36f7d2f73b98}">
+        <p14:section name="Proposed Solution" id="{633092c1-5ca8-66b3-f7b0-80363a0d101d}">
           <p14:sldIdLst>
             <p14:sldId id="259"/>
             <p14:sldId id="260"/>
@@ -141,39 +141,39 @@
             <p14:sldId id="262"/>
           </p14:sldIdLst>
         </p14:section>
-        <p14:section name="Technology / Tech Stack" id="{9a78d142-f870-16ff-1826-1514efe5b176}">
+        <p14:section name="Technology / Tech Stack" id="{495f3bf1-fc1a-9a7f-3900-6381e8c9b898}">
           <p14:sldIdLst>
             <p14:sldId id="263"/>
           </p14:sldIdLst>
         </p14:section>
-        <p14:section name="USP" id="{72afe650-131d-0ace-5703-f5ea16892b5e}">
+        <p14:section name="USP" id="{ceba2254-c041-5063-9f58-1afac3b0f1aa}">
           <p14:sldIdLst>
             <p14:sldId id="264"/>
             <p14:sldId id="265"/>
             <p14:sldId id="266"/>
           </p14:sldIdLst>
         </p14:section>
-        <p14:section name="Impact &amp; Benefits" id="{0ce2509f-7a12-438c-10bd-cc38b7d7d80d}">
+        <p14:section name="Impact &amp; Benefits" id="{e17268b4-5510-41ec-6301-0c9e2eb3016d}">
           <p14:sldIdLst>
             <p14:sldId id="267"/>
           </p14:sldIdLst>
         </p14:section>
-        <p14:section name="Business Model" id="{f7b03933-4767-cac2-2e56-aee7eaa64a15}">
+        <p14:section name="Business Model" id="{ae947d4e-0d62-e871-fa18-62c3c8e426a3}">
           <p14:sldIdLst>
             <p14:sldId id="268"/>
           </p14:sldIdLst>
         </p14:section>
-        <p14:section name="Roadmap &amp; Ask" id="{6c7cf144-69b3-d96c-c325-66efaf46b08a}">
+        <p14:section name="Roadmap &amp; Ask" id="{192e276d-4350-2b8c-80d3-014040429d9d}">
           <p14:sldIdLst>
             <p14:sldId id="269"/>
           </p14:sldIdLst>
         </p14:section>
-        <p14:section name="Close" id="{220536b2-9141-d37d-b6ad-0b0099cd0671}">
+        <p14:section name="Close" id="{cb55c556-bfab-3b73-4d57-a3ebe07d9268}">
           <p14:sldIdLst>
             <p14:sldId id="270"/>
           </p14:sldIdLst>
         </p14:section>
-        <p14:section name="Appendix" id="{8d719554-be34-2df0-845a-de54645c1db4}">
+        <p14:section name="Appendix" id="{d51118eb-01fd-06ae-94de-e44c503dd375}">
           <p14:sldIdLst>
             <p14:sldId id="271"/>
           </p14:sldIdLst>
@@ -1123,7 +1123,8 @@
             <a:r>
               <a:rPr lang="en-US" dirty="0"/>
               <a:t>SCRIPT (15s): "DukaanPulse turns payment signals into decisions a merchant can trust: every number from tested calculations, every claim checked, every action approved by the merchant. Evidence, not guesses. Decisions, not dashboards. Thank you — we would love to show you anything in more depth."
-TRANSITION: Open for questions; keep the app on the Ask page with the rules-only tab ready.</a:t>
+TRANSITION: Open for questions; keep the app on the Ask page with the rules-only tab ready.
+LINKS: The live demo (dukaanpulse-ai.vercel.app) runs Ask DukaanPulse in rule-based mode only; the local-model mode runs on our machine.</a:t>
             </a:r>
             <a:endParaRPr lang="en-US" dirty="0"/>
           </a:p>
@@ -2654,6 +2655,101 @@
         </p:nvSpPr>
         <p:spPr>
           <a:xfrm>
+            <a:off x="868680" y="5623560"/>
+            <a:ext cx="10972800" cy="320040"/>
+          </a:xfrm>
+          <a:prstGeom prst="rect">
+            <a:avLst/>
+          </a:prstGeom>
+          <a:noFill/>
+          <a:ln/>
+        </p:spPr>
+        <p:txBody>
+          <a:bodyPr wrap="square" lIns="0" tIns="0" rIns="0" bIns="0" rtlCol="0" anchor="t"/>
+          <a:lstStyle/>
+          <a:p>
+            <a:pPr indent="0" marL="0">
+              <a:buNone/>
+            </a:pPr>
+            <a:r>
+              <a:rPr lang="en-US" sz="1400" b="1" dirty="0">
+                <a:solidFill>
+                  <a:srgbClr val="4C8DFF"/>
+                </a:solidFill>
+                <a:latin typeface="Calibri" pitchFamily="34" charset="0"/>
+                <a:ea typeface="Calibri" pitchFamily="34" charset="-122"/>
+                <a:cs typeface="Calibri" pitchFamily="34" charset="-120"/>
+              </a:rPr>
+              <a:t>Live demo  </a:t>
+            </a:r>
+            <a:pPr indent="0" marL="0">
+              <a:buNone/>
+            </a:pPr>
+            <a:r>
+              <a:rPr lang="en-US" sz="1400" u="sng" dirty="0">
+                <a:solidFill>
+                  <a:srgbClr val="E7EBF3"/>
+                </a:solidFill>
+                <a:latin typeface="Calibri" pitchFamily="34" charset="0"/>
+                <a:ea typeface="Calibri" pitchFamily="34" charset="-122"/>
+                <a:cs typeface="Calibri" pitchFamily="34" charset="-120"/>
+                <a:hlinkClick r:id="rId2" invalidUrl="" action="" tgtFrame="" tooltip="" history="1" highlightClick="0" endSnd="0">
+                  <a:extLst>
+                    <a:ext uri="{A12FA001-AC4F-418D-AE19-62706E023703}">
+                      <ahyp:hlinkClr xmlns:ahyp="http://schemas.microsoft.com/office/drawing/2018/hyperlinkcolor" val="tx"/>
+                    </a:ext>
+                  </a:extLst>
+                </a:hlinkClick>
+              </a:rPr>
+              <a:t>dukaanpulse-ai.vercel.app</a:t>
+            </a:r>
+            <a:pPr indent="0" marL="0">
+              <a:buNone/>
+            </a:pPr>
+            <a:r>
+              <a:rPr lang="en-US" sz="1400" b="1" dirty="0">
+                <a:solidFill>
+                  <a:srgbClr val="4C8DFF"/>
+                </a:solidFill>
+                <a:latin typeface="Calibri" pitchFamily="34" charset="0"/>
+                <a:ea typeface="Calibri" pitchFamily="34" charset="-122"/>
+                <a:cs typeface="Calibri" pitchFamily="34" charset="-120"/>
+              </a:rPr>
+              <a:t>     Code  </a:t>
+            </a:r>
+            <a:pPr indent="0" marL="0">
+              <a:buNone/>
+            </a:pPr>
+            <a:r>
+              <a:rPr lang="en-US" sz="1400" u="sng" dirty="0">
+                <a:solidFill>
+                  <a:srgbClr val="E7EBF3"/>
+                </a:solidFill>
+                <a:latin typeface="Calibri" pitchFamily="34" charset="0"/>
+                <a:ea typeface="Calibri" pitchFamily="34" charset="-122"/>
+                <a:cs typeface="Calibri" pitchFamily="34" charset="-120"/>
+                <a:hlinkClick r:id="rId3" invalidUrl="" action="" tgtFrame="" tooltip="" history="1" highlightClick="0" endSnd="0">
+                  <a:extLst>
+                    <a:ext uri="{A12FA001-AC4F-418D-AE19-62706E023703}">
+                      <ahyp:hlinkClr xmlns:ahyp="http://schemas.microsoft.com/office/drawing/2018/hyperlinkcolor" val="tx"/>
+                    </a:ext>
+                  </a:extLst>
+                </a:hlinkClick>
+              </a:rPr>
+              <a:t>github.com/Thebinary110/dukaanpulse-ai</a:t>
+            </a:r>
+            <a:endParaRPr lang="en-US" sz="1400" dirty="0"/>
+          </a:p>
+        </p:txBody>
+      </p:sp>
+      <p:sp>
+        <p:nvSpPr>
+          <p:cNvPr id="6" name="Text 3"/>
+          <p:cNvSpPr txBox="1"/>
+          <p:nvPr/>
+        </p:nvSpPr>
+        <p:spPr>
+          <a:xfrm>
             <a:off x="868680" y="6080760"/>
             <a:ext cx="10058400" cy="274320"/>
           </a:xfrm>
@@ -8815,6 +8911,137 @@
               <a:t>Working prototype · synthetic data · local model + rules fallback · not affiliated with Paytm</a:t>
             </a:r>
             <a:endParaRPr lang="en-US" sz="1800" dirty="0"/>
+          </a:p>
+        </p:txBody>
+      </p:sp>
+      <p:sp>
+        <p:nvSpPr>
+          <p:cNvPr id="9" name="Shape 6"/>
+          <p:cNvSpPr/>
+          <p:nvPr/>
+        </p:nvSpPr>
+        <p:spPr>
+          <a:xfrm>
+            <a:off x="8138160" y="4892040"/>
+            <a:ext cx="3502152" cy="1051560"/>
+          </a:xfrm>
+          <a:prstGeom prst="roundRect">
+            <a:avLst>
+              <a:gd name="adj" fmla="val 10435"/>
+            </a:avLst>
+          </a:prstGeom>
+          <a:solidFill>
+            <a:srgbClr val="18213F"/>
+          </a:solidFill>
+          <a:ln w="12700">
+            <a:solidFill>
+              <a:srgbClr val="4C8DFF"/>
+            </a:solidFill>
+            <a:prstDash val="solid"/>
+          </a:ln>
+        </p:spPr>
+      </p:sp>
+      <p:sp>
+        <p:nvSpPr>
+          <p:cNvPr id="10" name="Text 7"/>
+          <p:cNvSpPr txBox="1"/>
+          <p:nvPr/>
+        </p:nvSpPr>
+        <p:spPr>
+          <a:xfrm>
+            <a:off x="8321040" y="4956048"/>
+            <a:ext cx="3200400" cy="914400"/>
+          </a:xfrm>
+          <a:prstGeom prst="rect">
+            <a:avLst/>
+          </a:prstGeom>
+          <a:noFill/>
+          <a:ln/>
+        </p:spPr>
+        <p:txBody>
+          <a:bodyPr wrap="square" lIns="0" tIns="0" rIns="0" bIns="0" rtlCol="0" anchor="ctr"/>
+          <a:lstStyle/>
+          <a:p>
+            <a:pPr indent="0" marL="0">
+              <a:buNone/>
+            </a:pPr>
+            <a:r>
+              <a:rPr lang="en-US" sz="1100" b="1" dirty="0">
+                <a:solidFill>
+                  <a:srgbClr val="4C8DFF"/>
+                </a:solidFill>
+                <a:latin typeface="Calibri" pitchFamily="34" charset="0"/>
+                <a:ea typeface="Calibri" pitchFamily="34" charset="-122"/>
+                <a:cs typeface="Calibri" pitchFamily="34" charset="-120"/>
+              </a:rPr>
+              <a:t>Live demo</a:t>
+            </a:r>
+            <a:endParaRPr lang="en-US" sz="1250" dirty="0"/>
+          </a:p>
+          <a:p>
+            <a:pPr indent="0" marL="0">
+              <a:buNone/>
+            </a:pPr>
+            <a:r>
+              <a:rPr lang="en-US" sz="1250" u="sng" dirty="0">
+                <a:solidFill>
+                  <a:srgbClr val="E7EBF3"/>
+                </a:solidFill>
+                <a:latin typeface="Calibri" pitchFamily="34" charset="0"/>
+                <a:ea typeface="Calibri" pitchFamily="34" charset="-122"/>
+                <a:cs typeface="Calibri" pitchFamily="34" charset="-120"/>
+                <a:hlinkClick r:id="rId2" invalidUrl="" action="" tgtFrame="" tooltip="" history="1" highlightClick="0" endSnd="0">
+                  <a:extLst>
+                    <a:ext uri="{A12FA001-AC4F-418D-AE19-62706E023703}">
+                      <ahyp:hlinkClr xmlns:ahyp="http://schemas.microsoft.com/office/drawing/2018/hyperlinkcolor" val="tx"/>
+                    </a:ext>
+                  </a:extLst>
+                </a:hlinkClick>
+              </a:rPr>
+              <a:t>dukaanpulse-ai.vercel.app</a:t>
+            </a:r>
+            <a:endParaRPr lang="en-US" sz="1250" dirty="0"/>
+          </a:p>
+          <a:p>
+            <a:pPr indent="0" marL="0">
+              <a:buNone/>
+            </a:pPr>
+            <a:r>
+              <a:rPr lang="en-US" sz="1100" b="1" dirty="0">
+                <a:solidFill>
+                  <a:srgbClr val="4C8DFF"/>
+                </a:solidFill>
+                <a:latin typeface="Calibri" pitchFamily="34" charset="0"/>
+                <a:ea typeface="Calibri" pitchFamily="34" charset="-122"/>
+                <a:cs typeface="Calibri" pitchFamily="34" charset="-120"/>
+              </a:rPr>
+              <a:t>Code</a:t>
+            </a:r>
+            <a:endParaRPr lang="en-US" sz="1250" dirty="0"/>
+          </a:p>
+          <a:p>
+            <a:pPr indent="0" marL="0">
+              <a:buNone/>
+            </a:pPr>
+            <a:r>
+              <a:rPr lang="en-US" sz="1250" u="sng" dirty="0">
+                <a:solidFill>
+                  <a:srgbClr val="E7EBF3"/>
+                </a:solidFill>
+                <a:latin typeface="Calibri" pitchFamily="34" charset="0"/>
+                <a:ea typeface="Calibri" pitchFamily="34" charset="-122"/>
+                <a:cs typeface="Calibri" pitchFamily="34" charset="-120"/>
+                <a:hlinkClick r:id="rId3" invalidUrl="" action="" tgtFrame="" tooltip="" history="1" highlightClick="0" endSnd="0">
+                  <a:extLst>
+                    <a:ext uri="{A12FA001-AC4F-418D-AE19-62706E023703}">
+                      <ahyp:hlinkClr xmlns:ahyp="http://schemas.microsoft.com/office/drawing/2018/hyperlinkcolor" val="tx"/>
+                    </a:ext>
+                  </a:extLst>
+                </a:hlinkClick>
+              </a:rPr>
+              <a:t>github.com/Thebinary110/dukaanpulse-ai</a:t>
+            </a:r>
+            <a:endParaRPr lang="en-US" sz="1250" dirty="0"/>
           </a:p>
         </p:txBody>
       </p:sp>

</xml_diff>